<commit_message>
Remove editor-specific docs and make repository portable
</commit_message>
<xml_diff>
--- a/docs/EchoLoom_Additional_Research_Sources_Appendix.pptx
+++ b/docs/EchoLoom_Additional_Research_Sources_Appendix.pptx
@@ -594,12 +594,12 @@
           </a:p>
           <a:p xmlns:a="http://schemas.openxmlformats.org/drawingml/2006/main">
             <a:r>
-              <a:t>- /Users/zihan/UofT/CSC454/EchoLoom_Interactive_Demo/docs/RESEARCH_BASIS.md</a:t>
-            </a:r>
-          </a:p>
-          <a:p xmlns:a="http://schemas.openxmlformats.org/drawingml/2006/main">
-            <a:r>
-              <a:t>- /Users/zihan/UofT/CSC454/EchoLoom_Interactive_Demo/docs/RESEARCH_TRACEABILITY.md</a:t>
+              <a:t>- docs/RESEARCH_BASIS.md</a:t>
+            </a:r>
+          </a:p>
+          <a:p xmlns:a="http://schemas.openxmlformats.org/drawingml/2006/main">
+            <a:r>
+              <a:t>- docs/RESEARCH_TRACEABILITY.md</a:t>
             </a:r>
           </a:p>
           <a:p xmlns:a="http://schemas.openxmlformats.org/drawingml/2006/main">
@@ -699,47 +699,47 @@
           </a:p>
           <a:p xmlns:a="http://schemas.openxmlformats.org/drawingml/2006/main">
             <a:r>
-              <a:t>- /Users/zihan/UofT/CSC454/EchoLoom_Interactive_Demo/docs/PRODUCT_BRIEF.md</a:t>
-            </a:r>
-          </a:p>
-          <a:p xmlns:a="http://schemas.openxmlformats.org/drawingml/2006/main">
-            <a:r>
-              <a:t>- /Users/zihan/UofT/CSC454/EchoLoom_Interactive_Demo/docs/RESEARCH_BASIS.md</a:t>
-            </a:r>
-          </a:p>
-          <a:p xmlns:a="http://schemas.openxmlformats.org/drawingml/2006/main">
-            <a:r>
-              <a:t>- /Users/zihan/UofT/CSC454/EchoLoom_Interactive_Demo/docs/RESEARCH_TRACEABILITY.md</a:t>
-            </a:r>
-          </a:p>
-          <a:p xmlns:a="http://schemas.openxmlformats.org/drawingml/2006/main">
-            <a:r>
-              <a:t>- /Users/zihan/UofT/CSC454/EchoLoom_Interactive_Demo/docs/PRODUCT_SPEC.md</a:t>
-            </a:r>
-          </a:p>
-          <a:p xmlns:a="http://schemas.openxmlformats.org/drawingml/2006/main">
-            <a:r>
-              <a:t>- /Users/zihan/UofT/CSC454/EchoLoom_Interactive_Demo/docs/ARCHITECTURE.md</a:t>
-            </a:r>
-          </a:p>
-          <a:p xmlns:a="http://schemas.openxmlformats.org/drawingml/2006/main">
-            <a:r>
-              <a:t>- /Users/zihan/UofT/CSC454/EchoLoom_Interactive_Demo/docs/DEMO_FLOW.md</a:t>
-            </a:r>
-          </a:p>
-          <a:p xmlns:a="http://schemas.openxmlformats.org/drawingml/2006/main">
-            <a:r>
-              <a:t>- /Users/zihan/UofT/CSC454/EchoLoom_Interactive_Demo/PLANS.md</a:t>
-            </a:r>
-          </a:p>
-          <a:p xmlns:a="http://schemas.openxmlformats.org/drawingml/2006/main">
-            <a:r>
-              <a:t>- /Users/zihan/UofT/CSC454/EchoLoom_Interactive_Demo/tools/smoke-test.mjs</a:t>
-            </a:r>
-          </a:p>
-          <a:p xmlns:a="http://schemas.openxmlformats.org/drawingml/2006/main">
-            <a:r>
-              <a:t>- /Users/zihan/UofT/CSC454/EchoLoom_Interactive_Demo/tools/state-test.mjs</a:t>
+              <a:t>- docs/PRODUCT_BRIEF.md</a:t>
+            </a:r>
+          </a:p>
+          <a:p xmlns:a="http://schemas.openxmlformats.org/drawingml/2006/main">
+            <a:r>
+              <a:t>- docs/RESEARCH_BASIS.md</a:t>
+            </a:r>
+          </a:p>
+          <a:p xmlns:a="http://schemas.openxmlformats.org/drawingml/2006/main">
+            <a:r>
+              <a:t>- docs/RESEARCH_TRACEABILITY.md</a:t>
+            </a:r>
+          </a:p>
+          <a:p xmlns:a="http://schemas.openxmlformats.org/drawingml/2006/main">
+            <a:r>
+              <a:t>- docs/PRODUCT_SPEC.md</a:t>
+            </a:r>
+          </a:p>
+          <a:p xmlns:a="http://schemas.openxmlformats.org/drawingml/2006/main">
+            <a:r>
+              <a:t>- docs/ARCHITECTURE.md</a:t>
+            </a:r>
+          </a:p>
+          <a:p xmlns:a="http://schemas.openxmlformats.org/drawingml/2006/main">
+            <a:r>
+              <a:t>- docs/DEMO_FLOW.md</a:t>
+            </a:r>
+          </a:p>
+          <a:p xmlns:a="http://schemas.openxmlformats.org/drawingml/2006/main">
+            <a:r>
+              <a:t>- PLANS.md</a:t>
+            </a:r>
+          </a:p>
+          <a:p xmlns:a="http://schemas.openxmlformats.org/drawingml/2006/main">
+            <a:r>
+              <a:t>- tools/smoke-test.mjs</a:t>
+            </a:r>
+          </a:p>
+          <a:p xmlns:a="http://schemas.openxmlformats.org/drawingml/2006/main">
+            <a:r>
+              <a:t>- tools/state-test.mjs</a:t>
             </a:r>
           </a:p>
           <a:p xmlns:a="http://schemas.openxmlformats.org/drawingml/2006/main">

</xml_diff>